<commit_message>
Add Arabic (RTL) versions of the 7 CSS lesson decks
Co-Authored-By: Claude Sonnet 5.5 <noreply@anthropic.com>
Claude-Session: https://claude.ai/code/session_01MzgFKAuWShtwbNzuNAAhGP
</commit_message>
<xml_diff>
--- a/CSS_Course/decks/CSS_Lesson4_Flexbox.pptx
+++ b/CSS_Course/decks/CSS_Lesson4_Flexbox.pptx
@@ -1954,7 +1954,7 @@
           <a:bodyPr wrap="square" lIns="0" tIns="0" rIns="0" bIns="0" rtlCol="0" anchor="ctr"/>
           <a:lstStyle/>
           <a:p>
-            <a:pPr indent="0" marL="0">
+            <a:pPr algn="l" indent="0" marL="0">
               <a:buNone/>
             </a:pPr>
             <a:r>
@@ -2129,7 +2129,7 @@
           <a:bodyPr wrap="square" lIns="0" tIns="0" rIns="0" bIns="0" rtlCol="0" anchor="ctr"/>
           <a:lstStyle/>
           <a:p>
-            <a:pPr indent="0" marL="0">
+            <a:pPr algn="l" indent="0" marL="0">
               <a:buNone/>
             </a:pPr>
             <a:r>
@@ -2563,7 +2563,7 @@
           <a:bodyPr wrap="square" lIns="0" tIns="0" rIns="0" bIns="0" rtlCol="0" anchor="ctr"/>
           <a:lstStyle/>
           <a:p>
-            <a:pPr indent="0" marL="0">
+            <a:pPr algn="l" indent="0" marL="0">
               <a:buNone/>
             </a:pPr>
             <a:r>
@@ -6428,7 +6428,7 @@
         <p:spPr>
           <a:xfrm>
             <a:off x="6583680" y="1828800"/>
-            <a:ext cx="5059375" cy="2353809"/>
+            <a:ext cx="5059375" cy="2236360"/>
           </a:xfrm>
           <a:prstGeom prst="rect">
             <a:avLst/>
@@ -6609,7 +6609,7 @@
         <p:spPr>
           <a:xfrm>
             <a:off x="6583680" y="2231136"/>
-            <a:ext cx="5059375" cy="1951473"/>
+            <a:ext cx="5059375" cy="1834024"/>
           </a:xfrm>
           <a:prstGeom prst="rect">
             <a:avLst/>
@@ -6624,7 +6624,7 @@
         </p:nvSpPr>
         <p:spPr>
           <a:xfrm>
-            <a:off x="6583680" y="4411209"/>
+            <a:off x="6583680" y="4293760"/>
             <a:ext cx="5059375" cy="914400"/>
           </a:xfrm>
           <a:prstGeom prst="roundRect">
@@ -6646,7 +6646,7 @@
         </p:nvSpPr>
         <p:spPr>
           <a:xfrm>
-            <a:off x="6766560" y="4411209"/>
+            <a:off x="6766560" y="4293760"/>
             <a:ext cx="4693615" cy="914400"/>
           </a:xfrm>
           <a:prstGeom prst="rect">

</xml_diff>